<commit_message>
Validar datos contables, separar validación de IVA y total, ajustar duplicados contables y presentación
</commit_message>
<xml_diff>
--- a/Presentacion_Conciliador.pptx
+++ b/Presentacion_Conciliador.pptx
@@ -3329,7 +3329,7 @@
                   <a:schemeClr val="tx1"/>
                 </a:solidFill>
               </a:rPr>
-              <a:t>Total = base + IVA − retención</a:t>
+              <a:t>Total = base + IVA informado − retención</a:t>
             </a:r>
             <a:endParaRPr lang="en-US" sz="1300" dirty="0"/>
           </a:p>
@@ -3680,12 +3680,12 @@
               <a:buNone/>
             </a:pPr>
             <a:r>
-              <a:rPr lang="en-US" sz="1600" dirty="0">
+              <a:rPr lang="en-US" sz="1400" dirty="0">
                 <a:solidFill>
                   <a:schemeClr val="tx1"/>
                 </a:solidFill>
               </a:rPr>
-              <a:t>facturas procesadas</a:t>
+              <a:t>registros procesados, 48 facturas distintas</a:t>
             </a:r>
             <a:endParaRPr lang="en-US" sz="1600" dirty="0"/>
           </a:p>
@@ -3752,7 +3752,7 @@
               <a:buNone/>
             </a:pPr>
             <a:r>
-              <a:rPr lang="en-US" sz="1600" dirty="0">
+              <a:rPr lang="en-US" sz="1400" dirty="0">
                 <a:solidFill>
                   <a:schemeClr val="tx1"/>
                 </a:solidFill>
@@ -3824,7 +3824,7 @@
               <a:buNone/>
             </a:pPr>
             <a:r>
-              <a:rPr lang="en-US" sz="1600" dirty="0">
+              <a:rPr lang="en-US" sz="1400" dirty="0">
                 <a:solidFill>
                   <a:schemeClr val="tx1"/>
                 </a:solidFill>
@@ -3859,8 +3859,8 @@
         </p:nvSpPr>
         <p:spPr>
           <a:xfrm>
-            <a:off x="3840480" y="4315968"/>
-            <a:ext cx="4754880" cy="274320"/>
+            <a:off x="3840480" y="4297680"/>
+            <a:ext cx="4754880" cy="411480"/>
           </a:xfrm>
           <a:prstGeom prst="rect">
             <a:avLst/>
@@ -3881,7 +3881,7 @@
                   <a:schemeClr val="accent5"/>
                 </a:solidFill>
               </a:rPr>
-              <a:t>Una misma factura puede tener varias causas. Datos ficticios de ejemplo.</a:t>
+              <a:t>«Correcta» significa que pasó las validaciones del prototipo. Una misma factura puede tener varias causas. Datos ficticios de ejemplo.</a:t>
             </a:r>
             <a:endParaRPr lang="en-US" sz="1200" dirty="0"/>
           </a:p>
@@ -4110,7 +4110,7 @@
                   <a:schemeClr val="tx1"/>
                 </a:solidFill>
               </a:rPr>
-              <a:t>El cruce de los dos archivos se hace en segundos.</a:t>
+              <a:t>Se espera reducir el tiempo del cruce de los dos archivos.</a:t>
             </a:r>
             <a:endParaRPr lang="en-US" sz="1400" dirty="0"/>
           </a:p>

</xml_diff>

<commit_message>
Rechazar id_factura vacío en contabilidad, marcar sumas no calculables y actualizar presentación y README
</commit_message>
<xml_diff>
--- a/Presentacion_Conciliador.pptx
+++ b/Presentacion_Conciliador.pptx
@@ -222,13 +222,13 @@
                 <c:ptCount val="7"/>
                 <c:lvl>
                   <c:pt idx="0">
+                    <c:v>Total mal calculado</c:v>
+                  </c:pt>
+                  <c:pt idx="1">
                     <c:v>Factura duplicada</c:v>
                   </c:pt>
-                  <c:pt idx="1">
+                  <c:pt idx="2">
                     <c:v>Sin registro contable</c:v>
-                  </c:pt>
-                  <c:pt idx="2">
-                    <c:v>Total mal calculado</c:v>
                   </c:pt>
                   <c:pt idx="3">
                     <c:v>Contabilización pendiente</c:v>
@@ -253,13 +253,13 @@
                 <c:formatCode>General</c:formatCode>
                 <c:ptCount val="7"/>
                 <c:pt idx="0">
-                  <c:v>4</c:v>
+                  <c:v>5</c:v>
                 </c:pt>
                 <c:pt idx="1">
                   <c:v>4</c:v>
                 </c:pt>
                 <c:pt idx="2">
-                  <c:v>3</c:v>
+                  <c:v>4</c:v>
                 </c:pt>
                 <c:pt idx="3">
                   <c:v>3</c:v>
@@ -982,7 +982,7 @@
           <a:p>
             <a:r>
               <a:rPr lang="en-US" dirty="0"/>
-              <a:t>El flujo tiene tres pasos. Se cargan los dos archivos, el sistema aplica las reglas y entrega un resumen con el detalle de cada factura. Las reglas son las del enunciado: IVA igual a base por tarifa, total igual a base más IVA menos retención, duplicados, facturas sin registro contable, estado pendiente y campos vacíos.</a:t>
+              <a:t>El flujo tiene tres pasos. Se cargan los dos archivos, el sistema aplica las reglas y entrega un resumen con el detalle de cada factura. Las reglas son las del enunciado: IVA igual a base por tarifa, total igual a base más IVA informado menos retención, duplicados, facturas sin registro contable, estado pendiente y campos vacíos.</a:t>
             </a:r>
             <a:endParaRPr lang="en-US" dirty="0"/>
           </a:p>
@@ -1070,7 +1070,7 @@
           <a:p>
             <a:r>
               <a:rPr lang="en-US" dirty="0"/>
-              <a:t>Con los archivos de ejemplo se procesan 50 filas de factura. 32 salen correctas y 18 con alguna inconsistencia, un 36%. Las causas más frecuentes son facturas duplicadas y facturas sin registro contable. Una factura puede tener más de una causa, por eso las barras suman más de 18. Los datos son ficticios.</a:t>
+              <a:t>Con los archivos de ejemplo se procesan 50 registros, que corresponden a 48 facturas distintas. 32 salen correctos, es decir, pasaron las validaciones del prototipo, y 18 con alguna inconsistencia, un 36%. La causa más frecuente es el total mal calculado, con 5 casos, seguida de facturas duplicadas y facturas sin registro contable, con 4 cada una. Una factura puede tener más de una causa, por eso las barras suman más de 18. Los datos son ficticios.</a:t>
             </a:r>
             <a:endParaRPr lang="en-US" dirty="0"/>
           </a:p>

</xml_diff>